<commit_message>
Add album cover to slide 5
Co-Authored-By: Claude Opus 5.5 <noreply@anthropic.com>
Claude-Session: https://claude.ai/code/session_016Ce846Uwi4MoBmUSJew8t7
</commit_message>
<xml_diff>
--- a/presentation/Noo_community_draft.pptx
+++ b/presentation/Noo_community_draft.pptx
@@ -2430,7 +2430,7 @@
         </p:nvSpPr>
         <p:spPr>
           <a:xfrm>
-            <a:off x="2107762" y="320675"/>
+            <a:off x="1042408" y="320675"/>
             <a:ext cx="6709934" cy="450893"/>
           </a:xfrm>
           <a:prstGeom prst="rect">
@@ -2461,7 +2461,7 @@
                 <a:ea typeface="Inter Light" panose="020B0502030000000004" pitchFamily="34" charset="0"/>
                 <a:cs typeface="Arial" panose="020B0604020202020204" pitchFamily="34" charset="0"/>
               </a:rPr>
-              <a:t>ОПИСАНИЕ</a:t>
+              <a:t>ANTON BATAGOV — MADE IN 1993</a:t>
             </a:r>
             <a:endParaRPr lang="ru-RU" sz="2400" dirty="0">
               <a:solidFill>
@@ -2504,7 +2504,7 @@
         </p:blipFill>
         <p:spPr>
           <a:xfrm>
-            <a:off x="2276016" y="2440785"/>
+            <a:off x="1210661" y="2440785"/>
             <a:ext cx="6373427" cy="6426985"/>
           </a:xfrm>
           <a:prstGeom prst="rect">
@@ -2514,26 +2514,23 @@
       </p:pic>
       <p:pic>
         <p:nvPicPr>
-          <p:cNvPr id="183" name="object 4">
-            <a:extLst>
-              <a:ext uri="{FF2B5EF4-FFF2-40B4-BE49-F238E27FC236}">
-                <a16:creationId xmlns:a16="http://schemas.microsoft.com/office/drawing/2014/main" id="{791CAE22-F560-40A3-BD0C-BA26623FFAC2}"/>
-              </a:ext>
-            </a:extLst>
-          </p:cNvPr>
-          <p:cNvPicPr/>
+          <p:cNvPr id="183" name="Picture 182" descr="album.jpg"/>
+          <p:cNvPicPr>
+            <a:picLocks noChangeAspect="1"/>
+          </p:cNvPicPr>
           <p:nvPr/>
         </p:nvPicPr>
         <p:blipFill>
-          <a:blip r:embed="rId4" cstate="print"/>
+          <a:blip r:embed="rId5"/>
+          <a:srcRect/>
           <a:stretch>
             <a:fillRect/>
           </a:stretch>
         </p:blipFill>
         <p:spPr>
           <a:xfrm>
-            <a:off x="10345234" y="0"/>
-            <a:ext cx="9758865" cy="11308556"/>
+            <a:off x="8794750" y="0"/>
+            <a:ext cx="11309350" cy="11309350"/>
           </a:xfrm>
           <a:prstGeom prst="rect">
             <a:avLst/>

</xml_diff>